<commit_message>
Add day 4 materials
</commit_message>
<xml_diff>
--- a/заняття_3/презентація/statistics_fundamentals.pptx
+++ b/заняття_3/презентація/statistics_fundamentals.pptx
@@ -7850,7 +7850,7 @@
               <a:buNone/>
             </a:pPr>
             <a:r>
-              <a:rPr lang="en-US" sz="1250" dirty="0" err="1">
+              <a:rPr lang="en-US" sz="1250" dirty="0">
                 <a:solidFill>
                   <a:srgbClr val="E0E8FF"/>
                 </a:solidFill>
@@ -7858,18 +7858,7 @@
                 <a:ea typeface="Consolas" pitchFamily="34" charset="-122"/>
                 <a:cs typeface="Consolas" pitchFamily="34" charset="-120"/>
               </a:rPr>
-              <a:t>corr_matrix</a:t>
-            </a:r>
-            <a:r>
-              <a:rPr lang="en-US" sz="1250" dirty="0">
-                <a:solidFill>
-                  <a:srgbClr val="E0E8FF"/>
-                </a:solidFill>
-                <a:latin typeface="Consolas" pitchFamily="34" charset="0"/>
-                <a:ea typeface="Consolas" pitchFamily="34" charset="-122"/>
-                <a:cs typeface="Consolas" pitchFamily="34" charset="-120"/>
-              </a:rPr>
-              <a:t> = df[nums].corr()</a:t>
+              <a:t>corr_matrix = df[nums].corr()</a:t>
             </a:r>
             <a:endParaRPr lang="en-US" sz="1250" dirty="0"/>
           </a:p>
@@ -9314,7 +9303,7 @@
         </p:nvSpPr>
         <p:spPr>
           <a:xfrm>
-            <a:off x="960120" y="1051560"/>
+            <a:off x="937260" y="1115568"/>
             <a:ext cx="3017520" cy="237744"/>
           </a:xfrm>
           <a:prstGeom prst="rect">
@@ -9497,7 +9486,7 @@
         </p:nvSpPr>
         <p:spPr>
           <a:xfrm>
-            <a:off x="960120" y="1627632"/>
+            <a:off x="937260" y="1685054"/>
             <a:ext cx="3017520" cy="237744"/>
           </a:xfrm>
           <a:prstGeom prst="rect">
@@ -9680,7 +9669,7 @@
         </p:nvSpPr>
         <p:spPr>
           <a:xfrm>
-            <a:off x="960120" y="2203704"/>
+            <a:off x="937260" y="2267712"/>
             <a:ext cx="3017520" cy="237744"/>
           </a:xfrm>
           <a:prstGeom prst="rect">
@@ -9863,7 +9852,7 @@
         </p:nvSpPr>
         <p:spPr>
           <a:xfrm>
-            <a:off x="960120" y="2779776"/>
+            <a:off x="937260" y="2834640"/>
             <a:ext cx="3017520" cy="237744"/>
           </a:xfrm>
           <a:prstGeom prst="rect">
@@ -10046,7 +10035,7 @@
         </p:nvSpPr>
         <p:spPr>
           <a:xfrm>
-            <a:off x="960120" y="3355848"/>
+            <a:off x="960120" y="3447288"/>
             <a:ext cx="3017520" cy="237744"/>
           </a:xfrm>
           <a:prstGeom prst="rect">
@@ -10229,7 +10218,7 @@
         </p:nvSpPr>
         <p:spPr>
           <a:xfrm>
-            <a:off x="960120" y="3931920"/>
+            <a:off x="937260" y="4032504"/>
             <a:ext cx="3017520" cy="237744"/>
           </a:xfrm>
           <a:prstGeom prst="rect">
@@ -10412,7 +10401,7 @@
         </p:nvSpPr>
         <p:spPr>
           <a:xfrm>
-            <a:off x="960120" y="4507992"/>
+            <a:off x="960120" y="4562856"/>
             <a:ext cx="3017520" cy="237744"/>
           </a:xfrm>
           <a:prstGeom prst="rect">
@@ -11091,29 +11080,7 @@
                 <a:ea typeface="Calibri" pitchFamily="34" charset="-122"/>
                 <a:cs typeface="Calibri" pitchFamily="34" charset="-120"/>
               </a:rPr>
-              <a:t>Як кількома </a:t>
-            </a:r>
-            <a:r>
-              <a:rPr lang="uk-UA" sz="1250" dirty="0">
-                <a:solidFill>
-                  <a:srgbClr val="E0E8FF"/>
-                </a:solidFill>
-                <a:latin typeface="Calibri" pitchFamily="34" charset="0"/>
-                <a:ea typeface="Calibri" pitchFamily="34" charset="-122"/>
-                <a:cs typeface="Calibri" pitchFamily="34" charset="-120"/>
-              </a:rPr>
-              <a:t>способами</a:t>
-            </a:r>
-            <a:r>
-              <a:rPr lang="en-US" sz="1250" dirty="0">
-                <a:solidFill>
-                  <a:srgbClr val="E0E8FF"/>
-                </a:solidFill>
-                <a:latin typeface="Calibri" pitchFamily="34" charset="0"/>
-                <a:ea typeface="Calibri" pitchFamily="34" charset="-122"/>
-                <a:cs typeface="Calibri" pitchFamily="34" charset="-120"/>
-              </a:rPr>
-              <a:t> описати колонку і не зробити хибний висновок?</a:t>
+              <a:t>Як кількома статистиками описати колонку і не зробити хибний висновок?</a:t>
             </a:r>
             <a:endParaRPr lang="en-US" sz="1250" dirty="0"/>
           </a:p>
@@ -17550,7 +17517,7 @@
               <a:buNone/>
             </a:pPr>
             <a:r>
-              <a:rPr lang="en-US" sz="1250" dirty="0" err="1">
+              <a:rPr lang="en-US" sz="1250" dirty="0">
                 <a:solidFill>
                   <a:srgbClr val="00FF9F"/>
                 </a:solidFill>
@@ -17558,57 +17525,24 @@
                 <a:ea typeface="Consolas" pitchFamily="34" charset="-122"/>
                 <a:cs typeface="Consolas" pitchFamily="34" charset="-120"/>
               </a:rPr>
-              <a:t>mode_pclass</a:t>
-            </a:r>
+              <a:t>mode_pclass = df['pclass'].mode()[0]</a:t>
+            </a:r>
+            <a:endParaRPr lang="en-US" sz="1250" dirty="0"/>
+          </a:p>
+          <a:p>
+            <a:pPr marL="0" indent="0">
+              <a:buNone/>
+            </a:pPr>
             <a:r>
               <a:rPr lang="en-US" sz="1250" dirty="0">
                 <a:solidFill>
-                  <a:srgbClr val="00FF9F"/>
+                  <a:srgbClr val="00D4FF"/>
                 </a:solidFill>
                 <a:latin typeface="Consolas" pitchFamily="34" charset="0"/>
                 <a:ea typeface="Consolas" pitchFamily="34" charset="-122"/>
                 <a:cs typeface="Consolas" pitchFamily="34" charset="-120"/>
               </a:rPr>
-              <a:t> = df['pclass'].mode()[0]</a:t>
-            </a:r>
-            <a:endParaRPr lang="en-US" sz="1250" dirty="0"/>
-          </a:p>
-          <a:p>
-            <a:pPr marL="0" indent="0">
-              <a:buNone/>
-            </a:pPr>
-            <a:r>
-              <a:rPr lang="en-US" sz="1250" dirty="0">
-                <a:solidFill>
-                  <a:srgbClr val="00D4FF"/>
-                </a:solidFill>
-                <a:latin typeface="Consolas" pitchFamily="34" charset="0"/>
-                <a:ea typeface="Consolas" pitchFamily="34" charset="-122"/>
-                <a:cs typeface="Consolas" pitchFamily="34" charset="-120"/>
-              </a:rPr>
-              <a:t>print(f'Найчастіший клас: {</a:t>
-            </a:r>
-            <a:r>
-              <a:rPr lang="en-US" sz="1250" dirty="0" err="1">
-                <a:solidFill>
-                  <a:srgbClr val="00D4FF"/>
-                </a:solidFill>
-                <a:latin typeface="Consolas" pitchFamily="34" charset="0"/>
-                <a:ea typeface="Consolas" pitchFamily="34" charset="-122"/>
-                <a:cs typeface="Consolas" pitchFamily="34" charset="-120"/>
-              </a:rPr>
-              <a:t>mode_pclass</a:t>
-            </a:r>
-            <a:r>
-              <a:rPr lang="en-US" sz="1250" dirty="0">
-                <a:solidFill>
-                  <a:srgbClr val="00D4FF"/>
-                </a:solidFill>
-                <a:latin typeface="Consolas" pitchFamily="34" charset="0"/>
-                <a:ea typeface="Consolas" pitchFamily="34" charset="-122"/>
-                <a:cs typeface="Consolas" pitchFamily="34" charset="-120"/>
-              </a:rPr>
-              <a:t>}')  # 3</a:t>
+              <a:t>print(f'Найчастіший клас: {mode_pclass}')  # 3</a:t>
             </a:r>
             <a:endParaRPr lang="en-US" sz="1250" dirty="0"/>
           </a:p>
@@ -19061,7 +18995,29 @@
                 <a:ea typeface="Consolas" pitchFamily="34" charset="-122"/>
                 <a:cs typeface="Consolas" pitchFamily="34" charset="-120"/>
               </a:rPr>
-              <a:t>print(df[col &gt; 75])  # 2 записи — реально?</a:t>
+              <a:t>print(df[col &gt; </a:t>
+            </a:r>
+            <a:r>
+              <a:rPr lang="uk-UA" sz="1250" dirty="0">
+                <a:solidFill>
+                  <a:srgbClr val="00D4FF"/>
+                </a:solidFill>
+                <a:latin typeface="Consolas" pitchFamily="34" charset="0"/>
+                <a:ea typeface="Consolas" pitchFamily="34" charset="-122"/>
+                <a:cs typeface="Consolas" pitchFamily="34" charset="-120"/>
+              </a:rPr>
+              <a:t>9</a:t>
+            </a:r>
+            <a:r>
+              <a:rPr lang="en-US" sz="1250" dirty="0">
+                <a:solidFill>
+                  <a:srgbClr val="00D4FF"/>
+                </a:solidFill>
+                <a:latin typeface="Consolas" pitchFamily="34" charset="0"/>
+                <a:ea typeface="Consolas" pitchFamily="34" charset="-122"/>
+                <a:cs typeface="Consolas" pitchFamily="34" charset="-120"/>
+              </a:rPr>
+              <a:t>5])  # 2 записи — реально?</a:t>
             </a:r>
           </a:p>
           <a:p>

</xml_diff>